<commit_message>
pitch: slides 2-8 restyled to match saud's page-1 scale (Arial Black display, 46pt stat numerals, 40pt hero stat); team name ALL STARS in
</commit_message>
<xml_diff>
--- a/pitch/Dhaal-HackX-submission-v2.pptx
+++ b/pitch/Dhaal-HackX-submission-v2.pptx
@@ -3418,19 +3418,19 @@
         <p:spPr>
           <a:xfrm>
             <a:off x="1524000" y="4472758"/>
-            <a:ext cx="9144000" cy="1655762"/>
+            <a:ext cx="9476232" cy="2385242"/>
           </a:xfrm>
         </p:spPr>
         <p:txBody>
           <a:bodyPr>
-            <a:normAutofit/>
+            <a:normAutofit fontScale="55000" lnSpcReduction="20000"/>
           </a:bodyPr>
           <a:lstStyle/>
           <a:p>
             <a:r>
-              <a:rPr lang="en-US" sz="2000" dirty="0" b="1">
-                <a:solidFill>
-                  <a:srgbClr val="156082"/>
+              <a:rPr lang="en-US" sz="5200" b="1" dirty="0">
+                <a:solidFill>
+                  <a:srgbClr val="F29FF9"/>
                 </a:solidFill>
                 <a:latin typeface="Arial"/>
               </a:rPr>
@@ -3439,20 +3439,47 @@
           </a:p>
           <a:p>
             <a:r>
-              <a:rPr lang="en-US" sz="1600" dirty="0" b="0">
-                <a:solidFill>
-                  <a:srgbClr val="0E2841"/>
+              <a:rPr lang="en-US" sz="3300" b="0" dirty="0">
+                <a:solidFill>
+                  <a:schemeClr val="bg1"/>
                 </a:solidFill>
                 <a:latin typeface="Calibri"/>
               </a:rPr>
-              <a:t>Team Name: [Your Team Name]</a:t>
-            </a:r>
-          </a:p>
-          <a:p>
-            <a:r>
-              <a:rPr lang="en-US" sz="1600" dirty="0" b="0">
+              <a:t>Team</a:t>
+            </a:r>
+            <a:r>
+              <a:rPr lang="en-US" sz="3300" b="0" dirty="0">
                 <a:solidFill>
                   <a:srgbClr val="0E2841"/>
+                </a:solidFill>
+                <a:latin typeface="Calibri"/>
+              </a:rPr>
+              <a:t> </a:t>
+            </a:r>
+            <a:r>
+              <a:rPr lang="en-US" sz="3300" b="0" dirty="0">
+                <a:solidFill>
+                  <a:schemeClr val="bg1"/>
+                </a:solidFill>
+                <a:latin typeface="Calibri"/>
+              </a:rPr>
+              <a:t>Name: </a:t>
+            </a:r>
+            <a:r>
+              <a:rPr lang="en-US" sz="3300" b="1" dirty="0">
+                <a:solidFill>
+                  <a:schemeClr val="bg1"/>
+                </a:solidFill>
+                <a:latin typeface="Calibri"/>
+              </a:rPr>
+              <a:t>ALL STARS</a:t>
+            </a:r>
+          </a:p>
+          <a:p>
+            <a:r>
+              <a:rPr lang="en-US" sz="3300" b="0" dirty="0">
+                <a:solidFill>
+                  <a:schemeClr val="bg1"/>
                 </a:solidFill>
                 <a:latin typeface="Calibri"/>
               </a:rPr>
@@ -3461,9 +3488,9 @@
           </a:p>
           <a:p>
             <a:r>
-              <a:rPr lang="en-US" sz="1600" dirty="0" b="0">
-                <a:solidFill>
-                  <a:srgbClr val="0E2841"/>
+              <a:rPr lang="en-US" sz="3300" b="0" dirty="0">
+                <a:solidFill>
+                  <a:schemeClr val="bg1"/>
                 </a:solidFill>
                 <a:latin typeface="Calibri"/>
               </a:rPr>
@@ -3472,9 +3499,9 @@
           </a:p>
           <a:p>
             <a:r>
-              <a:rPr sz="1600" b="0">
-                <a:solidFill>
-                  <a:srgbClr val="0E2841"/>
+              <a:rPr sz="3300" b="0" dirty="0">
+                <a:solidFill>
+                  <a:schemeClr val="bg1"/>
                 </a:solidFill>
                 <a:latin typeface="Calibri"/>
               </a:rPr>
@@ -3885,26 +3912,26 @@
           <a:noFill/>
         </p:spPr>
         <p:txBody>
-          <a:bodyPr wrap="square" lIns="0" rIns="0" tIns="0" bIns="0">
+          <a:bodyPr wrap="square" lIns="0" tIns="0" rIns="0" bIns="0">
             <a:spAutoFit/>
           </a:bodyPr>
           <a:lstStyle/>
           <a:p>
             <a:r>
-              <a:rPr sz="2400" b="1">
+              <a:rPr sz="2700" b="1">
                 <a:solidFill>
                   <a:srgbClr val="0E2841"/>
                 </a:solidFill>
-                <a:latin typeface="Arial"/>
+                <a:latin typeface="Arial Black"/>
               </a:rPr>
               <a:t>पैसे भेजने से पहले — एक जाँच।  </a:t>
             </a:r>
             <a:r>
-              <a:rPr sz="1700" b="1">
+              <a:rPr sz="1900" b="1">
                 <a:solidFill>
                   <a:srgbClr val="156082"/>
                 </a:solidFill>
-                <a:latin typeface="Arial"/>
+                <a:latin typeface="Arial Black"/>
               </a:rPr>
               <a:t>One check before you pay: paste it, photo it, or SPEAK it.</a:t>
             </a:r>
@@ -3952,7 +3979,7 @@
           </a:fontRef>
         </p:style>
         <p:txBody>
-          <a:bodyPr rtlCol="0" anchor="ctr" wrap="square" lIns="146304" rIns="146304" tIns="91440"/>
+          <a:bodyPr wrap="square" lIns="146304" tIns="91440" rIns="146304" rtlCol="0" anchor="ctr"/>
           <a:lstStyle/>
           <a:p>
             <a:pPr algn="ctr">
@@ -3961,11 +3988,11 @@
               </a:spcAft>
             </a:pPr>
             <a:r>
-              <a:rPr sz="1700" b="1">
+              <a:rPr sz="1900" b="1">
                 <a:solidFill>
                   <a:srgbClr val="156082"/>
                 </a:solidFill>
-                <a:latin typeface="Arial"/>
+                <a:latin typeface="Arial Black"/>
               </a:rPr>
               <a:t>जाँच · Check</a:t>
             </a:r>
@@ -4024,7 +4051,7 @@
           </a:fontRef>
         </p:style>
         <p:txBody>
-          <a:bodyPr rtlCol="0" anchor="ctr" wrap="square" lIns="146304" rIns="146304" tIns="91440"/>
+          <a:bodyPr wrap="square" lIns="146304" tIns="91440" rIns="146304" rtlCol="0" anchor="ctr"/>
           <a:lstStyle/>
           <a:p>
             <a:pPr algn="ctr">
@@ -4033,11 +4060,11 @@
               </a:spcAft>
             </a:pPr>
             <a:r>
-              <a:rPr sz="1700" b="1">
+              <a:rPr sz="1900" b="1">
                 <a:solidFill>
                   <a:srgbClr val="156082"/>
                 </a:solidFill>
-                <a:latin typeface="Arial"/>
+                <a:latin typeface="Arial Black"/>
               </a:rPr>
               <a:t>परिवार की ढाल · Guardian</a:t>
             </a:r>
@@ -4096,7 +4123,7 @@
           </a:fontRef>
         </p:style>
         <p:txBody>
-          <a:bodyPr rtlCol="0" anchor="ctr" wrap="square" lIns="146304" rIns="146304" tIns="91440"/>
+          <a:bodyPr wrap="square" lIns="146304" tIns="91440" rIns="146304" rtlCol="0" anchor="ctr"/>
           <a:lstStyle/>
           <a:p>
             <a:pPr algn="ctr">
@@ -4105,11 +4132,11 @@
               </a:spcAft>
             </a:pPr>
             <a:r>
-              <a:rPr sz="1700" b="1">
+              <a:rPr sz="1900" b="1">
                 <a:solidFill>
                   <a:srgbClr val="156082"/>
                 </a:solidFill>
-                <a:latin typeface="Arial"/>
+                <a:latin typeface="Arial Black"/>
               </a:rPr>
               <a:t>धोखों का नक्शा · Intel</a:t>
             </a:r>
@@ -4168,7 +4195,7 @@
           </a:fontRef>
         </p:style>
         <p:txBody>
-          <a:bodyPr rtlCol="0" anchor="ctr" wrap="square" lIns="146304" rIns="146304" tIns="91440"/>
+          <a:bodyPr wrap="square" lIns="146304" tIns="91440" rIns="146304" rtlCol="0" anchor="ctr"/>
           <a:lstStyle/>
           <a:p>
             <a:pPr algn="ctr">
@@ -4177,11 +4204,11 @@
               </a:spcAft>
             </a:pPr>
             <a:r>
-              <a:rPr sz="1700" b="1">
+              <a:rPr sz="1900" b="1">
                 <a:solidFill>
                   <a:srgbClr val="156082"/>
                 </a:solidFill>
-                <a:latin typeface="Arial"/>
+                <a:latin typeface="Arial Black"/>
               </a:rPr>
               <a:t>पहला घंटा · Recover</a:t>
             </a:r>
@@ -4216,26 +4243,26 @@
           <a:noFill/>
         </p:spPr>
         <p:txBody>
-          <a:bodyPr wrap="square" lIns="0" rIns="0" tIns="0" bIns="0">
+          <a:bodyPr wrap="square" lIns="0" tIns="0" rIns="0" bIns="0">
             <a:spAutoFit/>
           </a:bodyPr>
           <a:lstStyle/>
           <a:p>
             <a:r>
-              <a:rPr sz="1500" b="1">
+              <a:rPr sz="1700" b="1">
                 <a:solidFill>
                   <a:srgbClr val="0E2841"/>
                 </a:solidFill>
-                <a:latin typeface="Arial"/>
+                <a:latin typeface="Arial Black"/>
               </a:rPr>
               <a:t>The verdict is computed by rules — the AI explains it, and can never change it.   </a:t>
             </a:r>
             <a:r>
-              <a:rPr sz="1500" b="1">
+              <a:rPr sz="1700" b="1">
                 <a:solidFill>
                   <a:srgbClr val="C62828"/>
                 </a:solidFill>
-                <a:latin typeface="Arial"/>
+                <a:latin typeface="Arial Black"/>
               </a:rPr>
               <a:t>LIVE: dhaal-delta.vercel.app — check your own inbox in Q&amp;A.</a:t>
             </a:r>
@@ -4584,7 +4611,7 @@
           <a:noFill/>
         </p:spPr>
         <p:txBody>
-          <a:bodyPr wrap="square" lIns="0" rIns="0" tIns="0" bIns="0">
+          <a:bodyPr wrap="square" lIns="0" tIns="0" rIns="0" bIns="0">
             <a:spAutoFit/>
           </a:bodyPr>
           <a:lstStyle/>
@@ -4595,7 +4622,7 @@
               </a:spcAft>
             </a:pPr>
             <a:r>
-              <a:rPr sz="1400" b="0">
+              <a:rPr sz="1500" b="0">
                 <a:solidFill>
                   <a:srgbClr val="0E2841"/>
                 </a:solidFill>
@@ -4647,16 +4674,16 @@
           </a:fontRef>
         </p:style>
         <p:txBody>
-          <a:bodyPr rtlCol="0" anchor="ctr" wrap="square" lIns="109728" rIns="109728" tIns="54864" bIns="54864"/>
+          <a:bodyPr wrap="square" lIns="109728" tIns="54864" rIns="109728" bIns="54864" rtlCol="0" anchor="ctr"/>
           <a:lstStyle/>
           <a:p>
             <a:pPr algn="ctr"/>
             <a:r>
-              <a:rPr sz="1500" b="1">
+              <a:rPr sz="1700" b="1">
                 <a:solidFill>
                   <a:srgbClr val="0E2841"/>
                 </a:solidFill>
-                <a:latin typeface="Arial"/>
+                <a:latin typeface="Arial Black"/>
               </a:rPr>
               <a:t>INPUT</a:t>
             </a:r>
@@ -4716,6 +4743,7 @@
           <a:lstStyle/>
           <a:p>
             <a:pPr algn="ctr"/>
+            <a:endParaRPr/>
           </a:p>
         </p:txBody>
       </p:sp>
@@ -4760,16 +4788,16 @@
           </a:fontRef>
         </p:style>
         <p:txBody>
-          <a:bodyPr rtlCol="0" anchor="ctr" wrap="square" lIns="109728" rIns="109728" tIns="54864" bIns="54864"/>
+          <a:bodyPr wrap="square" lIns="109728" tIns="54864" rIns="109728" bIns="54864" rtlCol="0" anchor="ctr"/>
           <a:lstStyle/>
           <a:p>
             <a:pPr algn="ctr"/>
             <a:r>
-              <a:rPr sz="1700" b="1">
+              <a:rPr sz="1900" b="1">
                 <a:solidFill>
                   <a:srgbClr val="FFFFFF"/>
                 </a:solidFill>
-                <a:latin typeface="Arial"/>
+                <a:latin typeface="Arial Black"/>
               </a:rPr>
               <a:t>SIGNAL ENGINE</a:t>
             </a:r>
@@ -4829,6 +4857,7 @@
           <a:lstStyle/>
           <a:p>
             <a:pPr algn="ctr"/>
+            <a:endParaRPr/>
           </a:p>
         </p:txBody>
       </p:sp>
@@ -4873,16 +4902,16 @@
           </a:fontRef>
         </p:style>
         <p:txBody>
-          <a:bodyPr rtlCol="0" anchor="ctr" wrap="square" lIns="109728" rIns="109728" tIns="54864" bIns="54864"/>
+          <a:bodyPr wrap="square" lIns="109728" tIns="54864" rIns="109728" bIns="54864" rtlCol="0" anchor="ctr"/>
           <a:lstStyle/>
           <a:p>
             <a:pPr algn="ctr"/>
             <a:r>
-              <a:rPr sz="1400" b="1">
+              <a:rPr sz="1600" b="1">
                 <a:solidFill>
                   <a:srgbClr val="0E2841"/>
                 </a:solidFill>
-                <a:latin typeface="Arial"/>
+                <a:latin typeface="Arial Black"/>
               </a:rPr>
               <a:t>EXPLAIN &amp; SPEAK</a:t>
             </a:r>
@@ -4942,6 +4971,7 @@
           <a:lstStyle/>
           <a:p>
             <a:pPr algn="ctr"/>
+            <a:endParaRPr/>
           </a:p>
         </p:txBody>
       </p:sp>
@@ -4986,16 +5016,16 @@
           </a:fontRef>
         </p:style>
         <p:txBody>
-          <a:bodyPr rtlCol="0" anchor="ctr" wrap="square" lIns="109728" rIns="109728" tIns="54864" bIns="54864"/>
+          <a:bodyPr wrap="square" lIns="109728" tIns="54864" rIns="109728" bIns="54864" rtlCol="0" anchor="ctr"/>
           <a:lstStyle/>
           <a:p>
             <a:pPr algn="ctr"/>
             <a:r>
-              <a:rPr sz="1300" b="1">
+              <a:rPr sz="1500" b="1">
                 <a:solidFill>
                   <a:srgbClr val="156082"/>
                 </a:solidFill>
-                <a:latin typeface="Arial"/>
+                <a:latin typeface="Arial Black"/>
               </a:rPr>
               <a:t>MongoDB Atlas</a:t>
             </a:r>
@@ -5031,7 +5061,7 @@
           <a:noFill/>
         </p:spPr>
         <p:txBody>
-          <a:bodyPr wrap="square" lIns="0" rIns="0" tIns="0" bIns="0">
+          <a:bodyPr wrap="square" lIns="0" tIns="0" rIns="0" bIns="0">
             <a:spAutoFit/>
           </a:bodyPr>
           <a:lstStyle/>
@@ -5045,11 +5075,11 @@
               </a:spcAft>
             </a:pPr>
             <a:r>
-              <a:rPr sz="1800" b="1">
+              <a:rPr sz="2000" b="1">
                 <a:solidFill>
                   <a:srgbClr val="156082"/>
                 </a:solidFill>
-                <a:latin typeface="Arial"/>
+                <a:latin typeface="Arial Black"/>
               </a:rPr>
               <a:t>Reliability engineering</a:t>
             </a:r>
@@ -5061,7 +5091,7 @@
               </a:spcAft>
             </a:pPr>
             <a:r>
-              <a:rPr sz="1400" b="0">
+              <a:rPr sz="1500" b="0">
                 <a:solidFill>
                   <a:srgbClr val="0E2841"/>
                 </a:solidFill>
@@ -5414,7 +5444,7 @@
           <a:noFill/>
         </p:spPr>
         <p:txBody>
-          <a:bodyPr wrap="square" lIns="0" rIns="0" tIns="0" bIns="0">
+          <a:bodyPr wrap="square" lIns="0" tIns="0" rIns="0" bIns="0">
             <a:spAutoFit/>
           </a:bodyPr>
           <a:lstStyle/>
@@ -5428,11 +5458,11 @@
               </a:spcAft>
             </a:pPr>
             <a:r>
-              <a:rPr sz="1800" b="1">
+              <a:rPr sz="2000" b="1">
                 <a:solidFill>
                   <a:srgbClr val="156082"/>
                 </a:solidFill>
-                <a:latin typeface="Arial"/>
+                <a:latin typeface="Arial Black"/>
               </a:rPr>
               <a:t>A public-safety poster, not a SaaS dashboard</a:t>
             </a:r>
@@ -5444,7 +5474,7 @@
               </a:spcAft>
             </a:pPr>
             <a:r>
-              <a:rPr sz="1400" b="0">
+              <a:rPr sz="1500" b="0">
                 <a:solidFill>
                   <a:srgbClr val="0E2841"/>
                 </a:solidFill>
@@ -5463,11 +5493,11 @@
               </a:spcAft>
             </a:pPr>
             <a:r>
-              <a:rPr sz="1800" b="1">
+              <a:rPr sz="2000" b="1">
                 <a:solidFill>
                   <a:srgbClr val="156082"/>
                 </a:solidFill>
-                <a:latin typeface="Arial"/>
+                <a:latin typeface="Arial Black"/>
               </a:rPr>
               <a:t>Built for the next billion users</a:t>
             </a:r>
@@ -5479,7 +5509,7 @@
               </a:spcAft>
             </a:pPr>
             <a:r>
-              <a:rPr sz="1400" b="0">
+              <a:rPr sz="1500" b="0">
                 <a:solidFill>
                   <a:srgbClr val="0E2841"/>
                 </a:solidFill>
@@ -5498,11 +5528,11 @@
               </a:spcAft>
             </a:pPr>
             <a:r>
-              <a:rPr sz="1800" b="1">
+              <a:rPr sz="2000" b="1">
                 <a:solidFill>
                   <a:srgbClr val="156082"/>
                 </a:solidFill>
-                <a:latin typeface="Arial"/>
+                <a:latin typeface="Arial Black"/>
               </a:rPr>
               <a:t>Dignity by design</a:t>
             </a:r>
@@ -5514,7 +5544,7 @@
               </a:spcAft>
             </a:pPr>
             <a:r>
-              <a:rPr sz="1400" b="0">
+              <a:rPr sz="1500" b="0">
                 <a:solidFill>
                   <a:srgbClr val="0E2841"/>
                 </a:solidFill>
@@ -5542,17 +5572,17 @@
           <a:noFill/>
         </p:spPr>
         <p:txBody>
-          <a:bodyPr wrap="square" lIns="0" rIns="0" tIns="0" bIns="0">
+          <a:bodyPr wrap="square" lIns="0" tIns="0" rIns="0" bIns="0">
             <a:spAutoFit/>
           </a:bodyPr>
           <a:lstStyle/>
           <a:p>
             <a:r>
-              <a:rPr sz="2400" b="1">
+              <a:rPr sz="2700" b="1">
                 <a:solidFill>
                   <a:srgbClr val="C62828"/>
                 </a:solidFill>
-                <a:latin typeface="Arial"/>
+                <a:latin typeface="Arial Black"/>
               </a:rPr>
               <a:t>Danger screams. Safety whispers.</a:t>
             </a:r>
@@ -5901,17 +5931,17 @@
           <a:noFill/>
         </p:spPr>
         <p:txBody>
-          <a:bodyPr wrap="square" lIns="0" rIns="0" tIns="0" bIns="0">
+          <a:bodyPr wrap="square" lIns="0" tIns="0" rIns="0" bIns="0">
             <a:spAutoFit/>
           </a:bodyPr>
           <a:lstStyle/>
           <a:p>
             <a:r>
-              <a:rPr sz="2300" b="1">
+              <a:rPr sz="2600" b="1">
                 <a:solidFill>
                   <a:srgbClr val="0E2841"/>
                 </a:solidFill>
-                <a:latin typeface="Arial"/>
+                <a:latin typeface="Arial Black"/>
               </a:rPr>
               <a:t>Not a concept — deployed, tested and durable tonight.</a:t>
             </a:r>
@@ -5959,16 +5989,16 @@
           </a:fontRef>
         </p:style>
         <p:txBody>
-          <a:bodyPr rtlCol="0" anchor="ctr" wrap="square" lIns="73152" rIns="73152" tIns="73152" bIns="54864"/>
+          <a:bodyPr wrap="square" lIns="73152" tIns="73152" rIns="73152" bIns="54864" rtlCol="0" anchor="ctr"/>
           <a:lstStyle/>
           <a:p>
             <a:pPr algn="ctr"/>
             <a:r>
-              <a:rPr sz="3800" b="1">
+              <a:rPr sz="4600" b="1">
                 <a:solidFill>
                   <a:srgbClr val="0E2841"/>
                 </a:solidFill>
-                <a:latin typeface="Arial"/>
+                <a:latin typeface="Arial Black"/>
               </a:rPr>
               <a:t>49</a:t>
             </a:r>
@@ -5976,11 +6006,11 @@
           <a:p>
             <a:pPr algn="ctr"/>
             <a:r>
-              <a:rPr sz="1050" b="1">
+              <a:rPr sz="1250" b="1">
                 <a:solidFill>
                   <a:srgbClr val="515E6E"/>
                 </a:solidFill>
-                <a:latin typeface="Arial"/>
+                <a:latin typeface="Arial Black"/>
               </a:rPr>
               <a:t>AUTOMATED CHECKS GREEN</a:t>
             </a:r>
@@ -6028,16 +6058,16 @@
           </a:fontRef>
         </p:style>
         <p:txBody>
-          <a:bodyPr rtlCol="0" anchor="ctr" wrap="square" lIns="73152" rIns="73152" tIns="73152" bIns="54864"/>
+          <a:bodyPr wrap="square" lIns="73152" tIns="73152" rIns="73152" bIns="54864" rtlCol="0" anchor="ctr"/>
           <a:lstStyle/>
           <a:p>
             <a:pPr algn="ctr"/>
             <a:r>
-              <a:rPr sz="3800" b="1">
+              <a:rPr sz="4600" b="1">
                 <a:solidFill>
                   <a:srgbClr val="156082"/>
                 </a:solidFill>
-                <a:latin typeface="Arial"/>
+                <a:latin typeface="Arial Black"/>
               </a:rPr>
               <a:t>5.4s</a:t>
             </a:r>
@@ -6045,11 +6075,11 @@
           <a:p>
             <a:pPr algn="ctr"/>
             <a:r>
-              <a:rPr sz="1050" b="1">
+              <a:rPr sz="1250" b="1">
                 <a:solidFill>
                   <a:srgbClr val="515E6E"/>
                 </a:solidFill>
-                <a:latin typeface="Arial"/>
+                <a:latin typeface="Arial Black"/>
               </a:rPr>
               <a:t>P50 CHECK, LIVE PROD</a:t>
             </a:r>
@@ -6097,16 +6127,16 @@
           </a:fontRef>
         </p:style>
         <p:txBody>
-          <a:bodyPr rtlCol="0" anchor="ctr" wrap="square" lIns="73152" rIns="73152" tIns="73152" bIns="54864"/>
+          <a:bodyPr wrap="square" lIns="73152" tIns="73152" rIns="73152" bIns="54864" rtlCol="0" anchor="ctr"/>
           <a:lstStyle/>
           <a:p>
             <a:pPr algn="ctr"/>
             <a:r>
-              <a:rPr sz="3800" b="1">
+              <a:rPr sz="4600" b="1">
                 <a:solidFill>
                   <a:srgbClr val="156082"/>
                 </a:solidFill>
-                <a:latin typeface="Arial"/>
+                <a:latin typeface="Arial Black"/>
               </a:rPr>
               <a:t>450+</a:t>
             </a:r>
@@ -6114,11 +6144,11 @@
           <a:p>
             <a:pPr algn="ctr"/>
             <a:r>
-              <a:rPr sz="1050" b="1">
+              <a:rPr sz="1250" b="1">
                 <a:solidFill>
                   <a:srgbClr val="515E6E"/>
                 </a:solidFill>
-                <a:latin typeface="Arial"/>
+                <a:latin typeface="Arial Black"/>
               </a:rPr>
               <a:t>VERIFIED REPORTS IN ATLAS</a:t>
             </a:r>
@@ -6166,16 +6196,16 @@
           </a:fontRef>
         </p:style>
         <p:txBody>
-          <a:bodyPr rtlCol="0" anchor="ctr" wrap="square" lIns="73152" rIns="73152" tIns="73152" bIns="54864"/>
+          <a:bodyPr wrap="square" lIns="73152" tIns="73152" rIns="73152" bIns="54864" rtlCol="0" anchor="ctr"/>
           <a:lstStyle/>
           <a:p>
             <a:pPr algn="ctr"/>
             <a:r>
-              <a:rPr sz="3800" b="1">
+              <a:rPr sz="4600" b="1">
                 <a:solidFill>
                   <a:srgbClr val="C62828"/>
                 </a:solidFill>
-                <a:latin typeface="Arial"/>
+                <a:latin typeface="Arial Black"/>
               </a:rPr>
               <a:t>₹0</a:t>
             </a:r>
@@ -6183,11 +6213,11 @@
           <a:p>
             <a:pPr algn="ctr"/>
             <a:r>
-              <a:rPr sz="1050" b="1">
+              <a:rPr sz="1250" b="1">
                 <a:solidFill>
                   <a:srgbClr val="515E6E"/>
                 </a:solidFill>
-                <a:latin typeface="Arial"/>
+                <a:latin typeface="Arial Black"/>
               </a:rPr>
               <a:t>INFRA — FREE TIERS</a:t>
             </a:r>
@@ -6211,7 +6241,7 @@
           <a:noFill/>
         </p:spPr>
         <p:txBody>
-          <a:bodyPr wrap="square" lIns="0" rIns="0" tIns="0" bIns="0">
+          <a:bodyPr wrap="square" lIns="0" tIns="0" rIns="0" bIns="0">
             <a:spAutoFit/>
           </a:bodyPr>
           <a:lstStyle/>
@@ -6225,11 +6255,11 @@
               </a:spcAft>
             </a:pPr>
             <a:r>
-              <a:rPr sz="1800" b="1">
+              <a:rPr sz="2000" b="1">
                 <a:solidFill>
                   <a:srgbClr val="156082"/>
                 </a:solidFill>
-                <a:latin typeface="Arial"/>
+                <a:latin typeface="Arial Black"/>
               </a:rPr>
               <a:t>Live now</a:t>
             </a:r>
@@ -6241,7 +6271,7 @@
               </a:spcAft>
             </a:pPr>
             <a:r>
-              <a:rPr sz="1400" b="0">
+              <a:rPr sz="1500" b="0">
                 <a:solidFill>
                   <a:srgbClr val="0E2841"/>
                 </a:solidFill>
@@ -6260,11 +6290,11 @@
               </a:spcAft>
             </a:pPr>
             <a:r>
-              <a:rPr sz="1800" b="1">
+              <a:rPr sz="2000" b="1">
                 <a:solidFill>
                   <a:srgbClr val="156082"/>
                 </a:solidFill>
-                <a:latin typeface="Arial"/>
+                <a:latin typeface="Arial Black"/>
               </a:rPr>
               <a:t>Risks &amp; mitigations</a:t>
             </a:r>
@@ -6276,7 +6306,7 @@
               </a:spcAft>
             </a:pPr>
             <a:r>
-              <a:rPr sz="1400" b="0">
+              <a:rPr sz="1500" b="0">
                 <a:solidFill>
                   <a:srgbClr val="0E2841"/>
                 </a:solidFill>
@@ -6629,26 +6659,26 @@
           <a:noFill/>
         </p:spPr>
         <p:txBody>
-          <a:bodyPr wrap="square" lIns="0" rIns="0" tIns="0" bIns="0">
+          <a:bodyPr wrap="square" lIns="0" tIns="0" rIns="0" bIns="0">
             <a:spAutoFit/>
           </a:bodyPr>
           <a:lstStyle/>
           <a:p>
             <a:r>
-              <a:rPr sz="3000" b="1">
+              <a:rPr sz="4000" b="1">
                 <a:solidFill>
                   <a:srgbClr val="C62828"/>
                 </a:solidFill>
-                <a:latin typeface="Arial"/>
+                <a:latin typeface="Arial Black"/>
               </a:rPr>
               <a:t>₹22,495 crore</a:t>
             </a:r>
             <a:r>
-              <a:rPr sz="1900" b="1">
+              <a:rPr sz="2100" b="1">
                 <a:solidFill>
                   <a:srgbClr val="0E2841"/>
                 </a:solidFill>
-                <a:latin typeface="Arial"/>
+                <a:latin typeface="Arial Black"/>
               </a:rPr>
               <a:t>  lost to cyber fraud in 2025 — and the victim pressed PAY themselves.</a:t>
             </a:r>
@@ -6672,7 +6702,7 @@
           <a:noFill/>
         </p:spPr>
         <p:txBody>
-          <a:bodyPr wrap="square" lIns="0" rIns="0" tIns="0" bIns="0">
+          <a:bodyPr wrap="square" lIns="0" tIns="0" rIns="0" bIns="0">
             <a:spAutoFit/>
           </a:bodyPr>
           <a:lstStyle/>
@@ -6683,7 +6713,7 @@
               </a:spcAft>
             </a:pPr>
             <a:r>
-              <a:rPr sz="1400" b="0">
+              <a:rPr sz="1500" b="0">
                 <a:solidFill>
                   <a:srgbClr val="0E2841"/>
                 </a:solidFill>
@@ -6735,16 +6765,16 @@
           </a:fontRef>
         </p:style>
         <p:txBody>
-          <a:bodyPr rtlCol="0" anchor="ctr" wrap="square" lIns="109728" rIns="109728" tIns="54864" bIns="54864"/>
+          <a:bodyPr wrap="square" lIns="109728" tIns="54864" rIns="109728" bIns="54864" rtlCol="0" anchor="ctr"/>
           <a:lstStyle/>
           <a:p>
             <a:pPr algn="ctr"/>
             <a:r>
-              <a:rPr sz="1350" b="1">
+              <a:rPr sz="1550" b="1">
                 <a:solidFill>
                   <a:srgbClr val="0E2841"/>
                 </a:solidFill>
-                <a:latin typeface="Arial"/>
+                <a:latin typeface="Arial Black"/>
               </a:rPr>
               <a:t>1 REPORT</a:t>
             </a:r>
@@ -6804,6 +6834,7 @@
           <a:lstStyle/>
           <a:p>
             <a:pPr algn="ctr"/>
+            <a:endParaRPr/>
           </a:p>
         </p:txBody>
       </p:sp>
@@ -6848,16 +6879,16 @@
           </a:fontRef>
         </p:style>
         <p:txBody>
-          <a:bodyPr rtlCol="0" anchor="ctr" wrap="square" lIns="109728" rIns="109728" tIns="54864" bIns="54864"/>
+          <a:bodyPr wrap="square" lIns="109728" tIns="54864" rIns="109728" bIns="54864" rtlCol="0" anchor="ctr"/>
           <a:lstStyle/>
           <a:p>
             <a:pPr algn="ctr"/>
             <a:r>
-              <a:rPr sz="1350" b="1">
+              <a:rPr sz="1550" b="1">
                 <a:solidFill>
                   <a:srgbClr val="0E2841"/>
                 </a:solidFill>
-                <a:latin typeface="Arial"/>
+                <a:latin typeface="Arial Black"/>
               </a:rPr>
               <a:t>HUMAN VERIFY</a:t>
             </a:r>
@@ -6917,6 +6948,7 @@
           <a:lstStyle/>
           <a:p>
             <a:pPr algn="ctr"/>
+            <a:endParaRPr/>
           </a:p>
         </p:txBody>
       </p:sp>
@@ -6961,16 +6993,16 @@
           </a:fontRef>
         </p:style>
         <p:txBody>
-          <a:bodyPr rtlCol="0" anchor="ctr" wrap="square" lIns="109728" rIns="109728" tIns="54864" bIns="54864"/>
+          <a:bodyPr wrap="square" lIns="109728" tIns="54864" rIns="109728" bIns="54864" rtlCol="0" anchor="ctr"/>
           <a:lstStyle/>
           <a:p>
             <a:pPr algn="ctr"/>
             <a:r>
-              <a:rPr sz="1350" b="1">
+              <a:rPr sz="1550" b="1">
                 <a:solidFill>
                   <a:srgbClr val="0E2841"/>
                 </a:solidFill>
-                <a:latin typeface="Arial"/>
+                <a:latin typeface="Arial Black"/>
               </a:rPr>
               <a:t>BLOCKLIST LIVE</a:t>
             </a:r>
@@ -7030,6 +7062,7 @@
           <a:lstStyle/>
           <a:p>
             <a:pPr algn="ctr"/>
+            <a:endParaRPr/>
           </a:p>
         </p:txBody>
       </p:sp>
@@ -7074,16 +7107,16 @@
           </a:fontRef>
         </p:style>
         <p:txBody>
-          <a:bodyPr rtlCol="0" anchor="ctr" wrap="square" lIns="109728" rIns="109728" tIns="54864" bIns="54864"/>
+          <a:bodyPr wrap="square" lIns="109728" tIns="54864" rIns="109728" bIns="54864" rtlCol="0" anchor="ctr"/>
           <a:lstStyle/>
           <a:p>
             <a:pPr algn="ctr"/>
             <a:r>
-              <a:rPr sz="1350" b="1">
+              <a:rPr sz="1550" b="1">
                 <a:solidFill>
                   <a:srgbClr val="2E7D32"/>
                 </a:solidFill>
-                <a:latin typeface="Arial"/>
+                <a:latin typeface="Arial Black"/>
               </a:rPr>
               <a:t>EVERYONE SHIELDED</a:t>
             </a:r>
@@ -7119,17 +7152,17 @@
           <a:noFill/>
         </p:spPr>
         <p:txBody>
-          <a:bodyPr wrap="square" lIns="0" rIns="0" tIns="0" bIns="0">
+          <a:bodyPr wrap="square" lIns="0" tIns="0" rIns="0" bIns="0">
             <a:spAutoFit/>
           </a:bodyPr>
           <a:lstStyle/>
           <a:p>
             <a:r>
-              <a:rPr sz="1400" b="1">
+              <a:rPr sz="1600" b="1">
                 <a:solidFill>
                   <a:srgbClr val="156082"/>
                 </a:solidFill>
-                <a:latin typeface="Arial"/>
+                <a:latin typeface="Arial Black"/>
               </a:rPr>
               <a:t>↻ herd immunity for fraud — the shield compounds with every user</a:t>
             </a:r>
@@ -7153,7 +7186,7 @@
           <a:noFill/>
         </p:spPr>
         <p:txBody>
-          <a:bodyPr wrap="square" lIns="0" rIns="0" tIns="0" bIns="0">
+          <a:bodyPr wrap="square" lIns="0" tIns="0" rIns="0" bIns="0">
             <a:spAutoFit/>
           </a:bodyPr>
           <a:lstStyle/>
@@ -7167,11 +7200,11 @@
               </a:spcAft>
             </a:pPr>
             <a:r>
-              <a:rPr sz="1800" b="1">
+              <a:rPr sz="2000" b="1">
                 <a:solidFill>
                   <a:srgbClr val="156082"/>
                 </a:solidFill>
-                <a:latin typeface="Arial"/>
+                <a:latin typeface="Arial Black"/>
               </a:rPr>
               <a:t>Who benefits</a:t>
             </a:r>
@@ -7183,7 +7216,7 @@
               </a:spcAft>
             </a:pPr>
             <a:r>
-              <a:rPr sz="1400" b="0">
+              <a:rPr sz="1500" b="0">
                 <a:solidFill>
                   <a:srgbClr val="0E2841"/>
                 </a:solidFill>
@@ -7536,7 +7569,7 @@
           <a:noFill/>
         </p:spPr>
         <p:txBody>
-          <a:bodyPr wrap="square" lIns="0" rIns="0" tIns="0" bIns="0">
+          <a:bodyPr wrap="square" lIns="0" tIns="0" rIns="0" bIns="0">
             <a:spAutoFit/>
           </a:bodyPr>
           <a:lstStyle/>
@@ -7547,11 +7580,11 @@
               </a:spcAft>
             </a:pPr>
             <a:r>
-              <a:rPr sz="2300" b="1">
+              <a:rPr sz="2600" b="1">
                 <a:solidFill>
                   <a:srgbClr val="0E2841"/>
                 </a:solidFill>
-                <a:latin typeface="Arial"/>
+                <a:latin typeface="Arial Black"/>
               </a:rPr>
               <a:t>Citizens: free forever. Institutions pay.</a:t>
             </a:r>
@@ -7563,7 +7596,7 @@
               </a:spcAft>
             </a:pPr>
             <a:r>
-              <a:rPr sz="1400" b="0">
+              <a:rPr sz="1500" b="0">
                 <a:solidFill>
                   <a:srgbClr val="0E2841"/>
                 </a:solidFill>
@@ -7582,11 +7615,11 @@
               </a:spcAft>
             </a:pPr>
             <a:r>
-              <a:rPr sz="1800" b="1">
+              <a:rPr sz="2000" b="1">
                 <a:solidFill>
                   <a:srgbClr val="156082"/>
                 </a:solidFill>
-                <a:latin typeface="Arial"/>
+                <a:latin typeface="Arial Black"/>
               </a:rPr>
               <a:t>Revenue — from those who bear today's fraud cost</a:t>
             </a:r>
@@ -7598,7 +7631,7 @@
               </a:spcAft>
             </a:pPr>
             <a:r>
-              <a:rPr sz="1400" b="0">
+              <a:rPr sz="1500" b="0">
                 <a:solidFill>
                   <a:srgbClr val="0E2841"/>
                 </a:solidFill>
@@ -7617,11 +7650,11 @@
               </a:spcAft>
             </a:pPr>
             <a:r>
-              <a:rPr sz="1800" b="1">
+              <a:rPr sz="2000" b="1">
                 <a:solidFill>
                   <a:srgbClr val="156082"/>
                 </a:solidFill>
-                <a:latin typeface="Arial"/>
+                <a:latin typeface="Arial Black"/>
               </a:rPr>
               <a:t>Sustainability &amp; moat</a:t>
             </a:r>
@@ -7633,7 +7666,7 @@
               </a:spcAft>
             </a:pPr>
             <a:r>
-              <a:rPr sz="1400" b="0">
+              <a:rPr sz="1500" b="0">
                 <a:solidFill>
                   <a:srgbClr val="0E2841"/>
                 </a:solidFill>
@@ -7986,7 +8019,7 @@
           <a:noFill/>
         </p:spPr>
         <p:txBody>
-          <a:bodyPr wrap="square" lIns="0" rIns="0" tIns="0" bIns="0">
+          <a:bodyPr wrap="square" lIns="0" tIns="0" rIns="0" bIns="0">
             <a:spAutoFit/>
           </a:bodyPr>
           <a:lstStyle/>
@@ -8000,11 +8033,11 @@
               </a:spcAft>
             </a:pPr>
             <a:r>
-              <a:rPr sz="1800" b="1">
+              <a:rPr sz="2000" b="1">
                 <a:solidFill>
                   <a:srgbClr val="156082"/>
                 </a:solidFill>
-                <a:latin typeface="Arial"/>
+                <a:latin typeface="Arial Black"/>
               </a:rPr>
               <a:t>Data sources (verified 11 Sep 2026)</a:t>
             </a:r>
@@ -8016,7 +8049,7 @@
               </a:spcAft>
             </a:pPr>
             <a:r>
-              <a:rPr sz="1400" b="0">
+              <a:rPr sz="1500" b="0">
                 <a:solidFill>
                   <a:srgbClr val="0E2841"/>
                 </a:solidFill>
@@ -8035,11 +8068,11 @@
               </a:spcAft>
             </a:pPr>
             <a:r>
-              <a:rPr sz="1800" b="1">
+              <a:rPr sz="2000" b="1">
                 <a:solidFill>
                   <a:srgbClr val="156082"/>
                 </a:solidFill>
-                <a:latin typeface="Arial"/>
+                <a:latin typeface="Arial Black"/>
               </a:rPr>
               <a:t>Domain research</a:t>
             </a:r>
@@ -8051,7 +8084,7 @@
               </a:spcAft>
             </a:pPr>
             <a:r>
-              <a:rPr sz="1400" b="0">
+              <a:rPr sz="1500" b="0">
                 <a:solidFill>
                   <a:srgbClr val="0E2841"/>
                 </a:solidFill>
@@ -8070,11 +8103,11 @@
               </a:spcAft>
             </a:pPr>
             <a:r>
-              <a:rPr sz="1800" b="1">
+              <a:rPr sz="2000" b="1">
                 <a:solidFill>
                   <a:srgbClr val="156082"/>
                 </a:solidFill>
-                <a:latin typeface="Arial"/>
+                <a:latin typeface="Arial Black"/>
               </a:rPr>
               <a:t>Build</a:t>
             </a:r>
@@ -8086,7 +8119,7 @@
               </a:spcAft>
             </a:pPr>
             <a:r>
-              <a:rPr sz="1400" b="0">
+              <a:rPr sz="1500" b="0">
                 <a:solidFill>
                   <a:srgbClr val="0E2841"/>
                 </a:solidFill>

</xml_diff>